<commit_message>
feat(ppt): embed real system UI screenshots in slides 5 and 7 for AI sharing deck
</commit_message>
<xml_diff>
--- a/Service_BOM_AI应用案例分享_精装重构版.pptx
+++ b/Service_BOM_AI应用案例分享_精装重构版.pptx
@@ -982,22 +982,17 @@
           <a:lstStyle/>
           <a:p>
             <a:r>
-              <a:t>大家看屏幕上的这三个典型案例，这是实际系统中每天都在处理的数据。</a:t>
-            </a:r>
-          </a:p>
-          <a:p>
-            <a:r>
-              <a:t>案例1中，工程师写了前缀‘变桨备件_’，大模型能理解这只是个分类，精准提取出真正的‘传感器撞块’；</a:t>
-            </a:r>
-          </a:p>
-          <a:p>
-            <a:r>
-              <a:t>案例2中，图号在最前面，名称和型号颠倒，大模型依然精准复原；</a:t>
-            </a:r>
-          </a:p>
-          <a:p>
-            <a:r>
-              <a:t>案例3更具价值，系统识别出‘Siemens’后，自动映射归一化为中文‘西门子’，这就从根源上杜绝了‘西门子’和‘Siemens’在数据库里变成两个不同物料的一物多码现象！</a:t>
+              <a:t>大家看屏幕左侧，这是实际系统中大模型提取弹窗的真实截图。</a:t>
+            </a:r>
+          </a:p>
+          <a:p>
+            <a:r>
+              <a:t>当输入非标描述‘变桨备件_传感器撞块_DBJ00.004.1386.01_电力电子’，点击大模型智能提取，不到1秒，系统自动抽离出真正的部件名、纯型号并自动标绿回填；</a:t>
+            </a:r>
+          </a:p>
+          <a:p>
+            <a:r>
+              <a:t>右侧展示了系统的三大核心处理能力：自动过滤‘变桨备件_’前缀噪声、识别颠倒词序、以及将‘Siemens’自动规范映射为中文‘西门子’，彻底消除一物多码。</a:t>
             </a:r>
           </a:p>
         </p:txBody>
@@ -1142,27 +1137,27 @@
           <a:lstStyle/>
           <a:p>
             <a:r>
-              <a:t>AI 技术必须服务于实际的工程规范。在 Service BOM 输出环节，我们做到了 100% 的受控闭环：</a:t>
-            </a:r>
-          </a:p>
-          <a:p>
-            <a:r>
-              <a:t>第一，封面严格套用公司 FDJL-JS-037 受控模板，项目代号、平台与文件名联动；</a:t>
-            </a:r>
-          </a:p>
-          <a:p>
-            <a:r>
-              <a:t>第二，完整的六级签字与 ECN 变更追溯；</a:t>
-            </a:r>
-          </a:p>
-          <a:p>
-            <a:r>
-              <a:t>第三，严格的 10/20/30 层级编号和黑点缩进；</a:t>
-            </a:r>
-          </a:p>
-          <a:p>
-            <a:r>
-              <a:t>第四，独立工程锁机制，多同事协作互不冲突覆盖。保证了工程严谨性。</a:t>
+              <a:t>各位请看大屏幕上的这张实机界面截图，这就是我们已经上线运行的 Service BOM 智能工作站。</a:t>
+            </a:r>
+          </a:p>
+          <a:p>
+            <a:r>
+              <a:t>大家可以看到，顶部显示的是我们真实的机型工程‘变桨系统SBOM_电力电子[WL平台][EW6.25-220]’，右侧带有只读工程保护锁；</a:t>
+            </a:r>
+          </a:p>
+          <a:p>
+            <a:r>
+              <a:t>下面的 BOM 清单中，大家一眼就能看到清晰的‘• 一级组件’、‘•• 二级’点阵层级缩进，以及‘10、20、30’规范步进序号；</a:t>
+            </a:r>
+          </a:p>
+          <a:p>
+            <a:r>
+              <a:t>同时每一行备件都关联了实物照片缩略图与技术手册调阅按钮。</a:t>
+            </a:r>
+          </a:p>
+          <a:p>
+            <a:r>
+              <a:t>右侧展示了我们严格遵循公司受控规范的四大支柱：统一命名、树状层级点阵、多模态图册与符合 FDJL-JS-037 规范的标准导出。这是看得见、摸得着的真实落地成果！</a:t>
             </a:r>
           </a:p>
         </p:txBody>
@@ -8918,7 +8913,208 @@
         <p:spPr>
           <a:xfrm>
             <a:off x="731520" y="1691640"/>
-            <a:ext cx="10728655" cy="1389888"/>
+            <a:ext cx="4846320" cy="4846320"/>
+          </a:xfrm>
+          <a:prstGeom prst="roundRect">
+            <a:avLst/>
+          </a:prstGeom>
+          <a:solidFill>
+            <a:srgbClr val="FFFFFF"/>
+          </a:solidFill>
+          <a:ln w="19050">
+            <a:solidFill>
+              <a:srgbClr val="1D4ED8"/>
+            </a:solidFill>
+          </a:ln>
+        </p:spPr>
+        <p:style>
+          <a:lnRef idx="1">
+            <a:schemeClr val="accent1"/>
+          </a:lnRef>
+          <a:fillRef idx="3">
+            <a:schemeClr val="accent1"/>
+          </a:fillRef>
+          <a:effectRef idx="2">
+            <a:schemeClr val="accent1"/>
+          </a:effectRef>
+          <a:fontRef idx="minor">
+            <a:schemeClr val="lt1"/>
+          </a:fontRef>
+        </p:style>
+        <p:txBody>
+          <a:bodyPr rtlCol="0" anchor="ctr"/>
+          <a:lstStyle/>
+          <a:p>
+            <a:pPr algn="ctr"/>
+          </a:p>
+        </p:txBody>
+      </p:sp>
+      <p:sp>
+        <p:nvSpPr>
+          <p:cNvPr id="7" name="Rounded Rectangle 6"/>
+          <p:cNvSpPr/>
+          <p:nvPr/>
+        </p:nvSpPr>
+        <p:spPr>
+          <a:xfrm>
+            <a:off x="731520" y="1691640"/>
+            <a:ext cx="4846320" cy="347472"/>
+          </a:xfrm>
+          <a:prstGeom prst="roundRect">
+            <a:avLst/>
+          </a:prstGeom>
+          <a:solidFill>
+            <a:srgbClr val="0F172A"/>
+          </a:solidFill>
+          <a:ln>
+            <a:noFill/>
+          </a:ln>
+        </p:spPr>
+        <p:style>
+          <a:lnRef idx="1">
+            <a:schemeClr val="accent1"/>
+          </a:lnRef>
+          <a:fillRef idx="3">
+            <a:schemeClr val="accent1"/>
+          </a:fillRef>
+          <a:effectRef idx="2">
+            <a:schemeClr val="accent1"/>
+          </a:effectRef>
+          <a:fontRef idx="minor">
+            <a:schemeClr val="lt1"/>
+          </a:fontRef>
+        </p:style>
+        <p:txBody>
+          <a:bodyPr rtlCol="0" anchor="ctr"/>
+          <a:lstStyle/>
+          <a:p>
+            <a:pPr algn="ctr">
+              <a:defRPr sz="1000" b="1">
+                <a:solidFill>
+                  <a:srgbClr val="FFFFFF"/>
+                </a:solidFill>
+                <a:latin typeface="微软雅黑"/>
+              </a:defRPr>
+            </a:pPr>
+            <a:r>
+              <a:t>✨ 大模型智能提取实机弹窗 (Live UI)</a:t>
+            </a:r>
+          </a:p>
+        </p:txBody>
+      </p:sp>
+      <p:pic>
+        <p:nvPicPr>
+          <p:cNvPr id="8" name="Picture 7" descr="ui_ai_demo_real.png"/>
+          <p:cNvPicPr>
+            <a:picLocks noChangeAspect="1"/>
+          </p:cNvPicPr>
+          <p:nvPr/>
+        </p:nvPicPr>
+        <p:blipFill>
+          <a:blip r:embed="rId2"/>
+          <a:stretch>
+            <a:fillRect/>
+          </a:stretch>
+        </p:blipFill>
+        <p:spPr>
+          <a:xfrm>
+            <a:off x="804672" y="2084831"/>
+            <a:ext cx="4700016" cy="3017520"/>
+          </a:xfrm>
+          <a:prstGeom prst="rect">
+            <a:avLst/>
+          </a:prstGeom>
+        </p:spPr>
+      </p:pic>
+      <p:sp>
+        <p:nvSpPr>
+          <p:cNvPr id="9" name="Rounded Rectangle 8"/>
+          <p:cNvSpPr/>
+          <p:nvPr/>
+        </p:nvSpPr>
+        <p:spPr>
+          <a:xfrm>
+            <a:off x="804672" y="5166360"/>
+            <a:ext cx="4700016" cy="1280160"/>
+          </a:xfrm>
+          <a:prstGeom prst="roundRect">
+            <a:avLst/>
+          </a:prstGeom>
+          <a:solidFill>
+            <a:srgbClr val="ECFDF5"/>
+          </a:solidFill>
+          <a:ln w="12700">
+            <a:solidFill>
+              <a:srgbClr val="A7F3D0"/>
+            </a:solidFill>
+          </a:ln>
+        </p:spPr>
+        <p:style>
+          <a:lnRef idx="1">
+            <a:schemeClr val="accent1"/>
+          </a:lnRef>
+          <a:fillRef idx="3">
+            <a:schemeClr val="accent1"/>
+          </a:fillRef>
+          <a:effectRef idx="2">
+            <a:schemeClr val="accent1"/>
+          </a:effectRef>
+          <a:fontRef idx="minor">
+            <a:schemeClr val="lt1"/>
+          </a:fontRef>
+        </p:style>
+        <p:txBody>
+          <a:bodyPr rtlCol="0" anchor="ctr" wrap="square"/>
+          <a:lstStyle/>
+          <a:p>
+            <a:pPr algn="ctr">
+              <a:defRPr sz="1100" b="1">
+                <a:solidFill>
+                  <a:srgbClr val="065F46"/>
+                </a:solidFill>
+                <a:latin typeface="微软雅黑"/>
+              </a:defRPr>
+            </a:pPr>
+            <a:r>
+              <a:t>⚡ 秒级云端推断 · 真实回填效果</a:t>
+            </a:r>
+          </a:p>
+          <a:p>
+            <a:pPr>
+              <a:spcBef>
+                <a:spcPts val="300"/>
+              </a:spcBef>
+              <a:defRPr sz="950">
+                <a:solidFill>
+                  <a:srgbClr val="475569"/>
+                </a:solidFill>
+                <a:latin typeface="微软雅黑"/>
+              </a:defRPr>
+            </a:pPr>
+            <a:r>
+              <a:t>✔ 单次推断响应实测仅 ~0.93s，连续录入零卡顿</a:t>
+            </a:r>
+            <a:br/>
+            <a:r>
+              <a:t>✔ 自动抽取名称、型号、厂商并绿框高亮回填</a:t>
+            </a:r>
+            <a:br/>
+            <a:r>
+              <a:t>✔ 普通办公电脑即可使用，零本地 GPU 门槛</a:t>
+            </a:r>
+          </a:p>
+        </p:txBody>
+      </p:sp>
+      <p:sp>
+        <p:nvSpPr>
+          <p:cNvPr id="10" name="Rounded Rectangle 9"/>
+          <p:cNvSpPr/>
+          <p:nvPr/>
+        </p:nvSpPr>
+        <p:spPr>
+          <a:xfrm>
+            <a:off x="5760720" y="1691640"/>
+            <a:ext cx="5699455" cy="1536192"/>
           </a:xfrm>
           <a:prstGeom prst="roundRect">
             <a:avLst/>
@@ -8956,14 +9152,14 @@
       </p:sp>
       <p:sp>
         <p:nvSpPr>
-          <p:cNvPr id="7" name="TextBox 6"/>
+          <p:cNvPr id="11" name="TextBox 10"/>
           <p:cNvSpPr txBox="1"/>
           <p:nvPr/>
         </p:nvSpPr>
         <p:spPr>
           <a:xfrm>
-            <a:off x="914400" y="1746504"/>
-            <a:ext cx="10332720" cy="320040"/>
+            <a:off x="5897880" y="1764792"/>
+            <a:ext cx="5394960" cy="292608"/>
           </a:xfrm>
           <a:prstGeom prst="rect">
             <a:avLst/>
@@ -8977,7 +9173,7 @@
           <a:lstStyle/>
           <a:p>
             <a:pPr>
-              <a:defRPr sz="1200" b="1">
+              <a:defRPr sz="1150" b="1">
                 <a:solidFill>
                   <a:srgbClr val="1E3A8A"/>
                 </a:solidFill>
@@ -8992,14 +9188,14 @@
       </p:sp>
       <p:sp>
         <p:nvSpPr>
-          <p:cNvPr id="8" name="Rounded Rectangle 7"/>
+          <p:cNvPr id="12" name="Rounded Rectangle 11"/>
           <p:cNvSpPr/>
           <p:nvPr/>
         </p:nvSpPr>
         <p:spPr>
           <a:xfrm>
-            <a:off x="914400" y="2130552"/>
-            <a:ext cx="3931920" cy="777240"/>
+            <a:off x="5897880" y="2093976"/>
+            <a:ext cx="5394960" cy="438912"/>
           </a:xfrm>
           <a:prstGeom prst="roundRect">
             <a:avLst/>
@@ -9040,43 +9236,32 @@
               </a:defRPr>
             </a:pPr>
             <a:r>
-              <a:t>📥 原始非标描述输入：</a:t>
-            </a:r>
-          </a:p>
-          <a:p>
-            <a:pPr>
-              <a:defRPr sz="1100" b="1">
-                <a:solidFill>
-                  <a:srgbClr val="0F172A"/>
-                </a:solidFill>
-                <a:latin typeface="Segoe UI"/>
-              </a:defRPr>
-            </a:pPr>
-            <a:r>
-              <a:t>变桨备件_传感器撞块_DBJ00.004.1386.01_电力电子</a:t>
-            </a:r>
-          </a:p>
-        </p:txBody>
-      </p:sp>
-      <p:sp>
-        <p:nvSpPr>
-          <p:cNvPr id="9" name="Right Arrow 8"/>
+              <a:t>📥 原始描述：变桨备件_传感器撞块_DBJ00.004.1386.01_电力电子</a:t>
+            </a:r>
+          </a:p>
+        </p:txBody>
+      </p:sp>
+      <p:sp>
+        <p:nvSpPr>
+          <p:cNvPr id="13" name="Rounded Rectangle 12"/>
           <p:cNvSpPr/>
           <p:nvPr/>
         </p:nvSpPr>
         <p:spPr>
           <a:xfrm>
-            <a:off x="4983480" y="2350008"/>
-            <a:ext cx="320040" cy="347472"/>
-          </a:xfrm>
-          <a:prstGeom prst="rightArrow">
-            <a:avLst/>
-          </a:prstGeom>
-          <a:solidFill>
-            <a:srgbClr val="1D4ED8"/>
+            <a:off x="5897880" y="2587752"/>
+            <a:ext cx="1755648" cy="548640"/>
+          </a:xfrm>
+          <a:prstGeom prst="roundRect">
+            <a:avLst/>
+          </a:prstGeom>
+          <a:solidFill>
+            <a:srgbClr val="ECFDF5"/>
           </a:solidFill>
           <a:ln>
-            <a:noFill/>
+            <a:solidFill>
+              <a:srgbClr val="A7F3D0"/>
+            </a:solidFill>
           </a:ln>
         </p:spPr>
         <p:style>
@@ -9094,23 +9279,33 @@
           </a:fontRef>
         </p:style>
         <p:txBody>
-          <a:bodyPr rtlCol="0" anchor="ctr"/>
-          <a:lstStyle/>
-          <a:p>
-            <a:pPr algn="ctr"/>
-          </a:p>
-        </p:txBody>
-      </p:sp>
-      <p:sp>
-        <p:nvSpPr>
-          <p:cNvPr id="10" name="Rounded Rectangle 9"/>
+          <a:bodyPr rtlCol="0" anchor="ctr" wrap="square"/>
+          <a:lstStyle/>
+          <a:p>
+            <a:pPr algn="ctr">
+              <a:defRPr sz="950" b="1">
+                <a:solidFill>
+                  <a:srgbClr val="047857"/>
+                </a:solidFill>
+                <a:latin typeface="微软雅黑"/>
+              </a:defRPr>
+            </a:pPr>
+            <a:r>
+              <a:t>✨ 名称：传感器撞块</a:t>
+            </a:r>
+          </a:p>
+        </p:txBody>
+      </p:sp>
+      <p:sp>
+        <p:nvSpPr>
+          <p:cNvPr id="14" name="Rounded Rectangle 13"/>
           <p:cNvSpPr/>
           <p:nvPr/>
         </p:nvSpPr>
         <p:spPr>
           <a:xfrm>
-            <a:off x="5440680" y="2130552"/>
-            <a:ext cx="1874519" cy="777240"/>
+            <a:off x="7708392" y="2587752"/>
+            <a:ext cx="1755648" cy="548640"/>
           </a:xfrm>
           <a:prstGeom prst="roundRect">
             <a:avLst/>
@@ -9143,7 +9338,7 @@
           <a:lstStyle/>
           <a:p>
             <a:pPr algn="ctr">
-              <a:defRPr sz="950">
+              <a:defRPr sz="950" b="1">
                 <a:solidFill>
                   <a:srgbClr val="047857"/>
                 </a:solidFill>
@@ -9151,34 +9346,21 @@
               </a:defRPr>
             </a:pPr>
             <a:r>
-              <a:t>✨ 物料名称</a:t>
-            </a:r>
-          </a:p>
-          <a:p>
-            <a:pPr>
-              <a:defRPr sz="1100" b="1">
-                <a:solidFill>
-                  <a:srgbClr val="0F172A"/>
-                </a:solidFill>
-                <a:latin typeface="微软雅黑"/>
-              </a:defRPr>
-            </a:pPr>
-            <a:r>
-              <a:t>传感器撞块</a:t>
-            </a:r>
-          </a:p>
-        </p:txBody>
-      </p:sp>
-      <p:sp>
-        <p:nvSpPr>
-          <p:cNvPr id="11" name="Rounded Rectangle 10"/>
+              <a:t>✨ 型号：DBJ00.004.1386.01</a:t>
+            </a:r>
+          </a:p>
+        </p:txBody>
+      </p:sp>
+      <p:sp>
+        <p:nvSpPr>
+          <p:cNvPr id="15" name="Rounded Rectangle 14"/>
           <p:cNvSpPr/>
           <p:nvPr/>
         </p:nvSpPr>
         <p:spPr>
           <a:xfrm>
-            <a:off x="7406640" y="2130552"/>
-            <a:ext cx="1874519" cy="777240"/>
+            <a:off x="9518904" y="2587752"/>
+            <a:ext cx="1755648" cy="548640"/>
           </a:xfrm>
           <a:prstGeom prst="roundRect">
             <a:avLst/>
@@ -9211,7 +9393,7 @@
           <a:lstStyle/>
           <a:p>
             <a:pPr algn="ctr">
-              <a:defRPr sz="950">
+              <a:defRPr sz="950" b="1">
                 <a:solidFill>
                   <a:srgbClr val="047857"/>
                 </a:solidFill>
@@ -9219,34 +9401,157 @@
               </a:defRPr>
             </a:pPr>
             <a:r>
-              <a:t>✨ 规格型号</a:t>
-            </a:r>
-          </a:p>
+              <a:t>✨ 厂商：电力电子</a:t>
+            </a:r>
+          </a:p>
+        </p:txBody>
+      </p:sp>
+      <p:sp>
+        <p:nvSpPr>
+          <p:cNvPr id="16" name="Rounded Rectangle 15"/>
+          <p:cNvSpPr/>
+          <p:nvPr/>
+        </p:nvSpPr>
+        <p:spPr>
+          <a:xfrm>
+            <a:off x="5760720" y="3337560"/>
+            <a:ext cx="5699455" cy="1536192"/>
+          </a:xfrm>
+          <a:prstGeom prst="roundRect">
+            <a:avLst/>
+          </a:prstGeom>
+          <a:solidFill>
+            <a:srgbClr val="FFFFFF"/>
+          </a:solidFill>
+          <a:ln w="12700">
+            <a:solidFill>
+              <a:srgbClr val="E2E8F0"/>
+            </a:solidFill>
+          </a:ln>
+        </p:spPr>
+        <p:style>
+          <a:lnRef idx="1">
+            <a:schemeClr val="accent1"/>
+          </a:lnRef>
+          <a:fillRef idx="3">
+            <a:schemeClr val="accent1"/>
+          </a:fillRef>
+          <a:effectRef idx="2">
+            <a:schemeClr val="accent1"/>
+          </a:effectRef>
+          <a:fontRef idx="minor">
+            <a:schemeClr val="lt1"/>
+          </a:fontRef>
+        </p:style>
+        <p:txBody>
+          <a:bodyPr rtlCol="0" anchor="ctr"/>
+          <a:lstStyle/>
+          <a:p>
+            <a:pPr algn="ctr"/>
+          </a:p>
+        </p:txBody>
+      </p:sp>
+      <p:sp>
+        <p:nvSpPr>
+          <p:cNvPr id="17" name="TextBox 16"/>
+          <p:cNvSpPr txBox="1"/>
+          <p:nvPr/>
+        </p:nvSpPr>
+        <p:spPr>
+          <a:xfrm>
+            <a:off x="5897880" y="3410712"/>
+            <a:ext cx="5394960" cy="292608"/>
+          </a:xfrm>
+          <a:prstGeom prst="rect">
+            <a:avLst/>
+          </a:prstGeom>
+          <a:noFill/>
+        </p:spPr>
+        <p:txBody>
+          <a:bodyPr wrap="none">
+            <a:spAutoFit/>
+          </a:bodyPr>
+          <a:lstStyle/>
           <a:p>
             <a:pPr>
-              <a:defRPr sz="1100" b="1">
-                <a:solidFill>
-                  <a:srgbClr val="0F172A"/>
-                </a:solidFill>
-                <a:latin typeface="微软雅黑"/>
-              </a:defRPr>
-            </a:pPr>
-            <a:r>
-              <a:t>DBJ00.004.1386.01</a:t>
-            </a:r>
-          </a:p>
-        </p:txBody>
-      </p:sp>
-      <p:sp>
-        <p:nvSpPr>
-          <p:cNvPr id="12" name="Rounded Rectangle 11"/>
+              <a:defRPr sz="1150" b="1">
+                <a:solidFill>
+                  <a:srgbClr val="1E3A8A"/>
+                </a:solidFill>
+                <a:latin typeface="微软雅黑"/>
+              </a:defRPr>
+            </a:pPr>
+            <a:r>
+              <a:t>案例 2：词序完全倒置混排（属性前置干扰）</a:t>
+            </a:r>
+          </a:p>
+        </p:txBody>
+      </p:sp>
+      <p:sp>
+        <p:nvSpPr>
+          <p:cNvPr id="18" name="Rounded Rectangle 17"/>
           <p:cNvSpPr/>
           <p:nvPr/>
         </p:nvSpPr>
         <p:spPr>
           <a:xfrm>
-            <a:off x="9372600" y="2130552"/>
-            <a:ext cx="1874519" cy="777240"/>
+            <a:off x="5897880" y="3739896"/>
+            <a:ext cx="5394960" cy="438912"/>
+          </a:xfrm>
+          <a:prstGeom prst="roundRect">
+            <a:avLst/>
+          </a:prstGeom>
+          <a:solidFill>
+            <a:srgbClr val="FFF1F2"/>
+          </a:solidFill>
+          <a:ln>
+            <a:solidFill>
+              <a:srgbClr val="FECDD3"/>
+            </a:solidFill>
+          </a:ln>
+        </p:spPr>
+        <p:style>
+          <a:lnRef idx="1">
+            <a:schemeClr val="accent1"/>
+          </a:lnRef>
+          <a:fillRef idx="3">
+            <a:schemeClr val="accent1"/>
+          </a:fillRef>
+          <a:effectRef idx="2">
+            <a:schemeClr val="accent1"/>
+          </a:effectRef>
+          <a:fontRef idx="minor">
+            <a:schemeClr val="lt1"/>
+          </a:fontRef>
+        </p:style>
+        <p:txBody>
+          <a:bodyPr rtlCol="0" anchor="ctr" wrap="square"/>
+          <a:lstStyle/>
+          <a:p>
+            <a:pPr algn="ctr">
+              <a:defRPr sz="950" b="1">
+                <a:solidFill>
+                  <a:srgbClr val="F43F5E"/>
+                </a:solidFill>
+                <a:latin typeface="微软雅黑"/>
+              </a:defRPr>
+            </a:pPr>
+            <a:r>
+              <a:t>📥 原始描述：支架_66-31-02-Q00448-00_限位开关支架_X3_SSB</a:t>
+            </a:r>
+          </a:p>
+        </p:txBody>
+      </p:sp>
+      <p:sp>
+        <p:nvSpPr>
+          <p:cNvPr id="19" name="Rounded Rectangle 18"/>
+          <p:cNvSpPr/>
+          <p:nvPr/>
+        </p:nvSpPr>
+        <p:spPr>
+          <a:xfrm>
+            <a:off x="5897880" y="4233672"/>
+            <a:ext cx="1755648" cy="548640"/>
           </a:xfrm>
           <a:prstGeom prst="roundRect">
             <a:avLst/>
@@ -9279,7 +9584,7 @@
           <a:lstStyle/>
           <a:p>
             <a:pPr algn="ctr">
-              <a:defRPr sz="950">
+              <a:defRPr sz="950" b="1">
                 <a:solidFill>
                   <a:srgbClr val="047857"/>
                 </a:solidFill>
@@ -9287,34 +9592,131 @@
               </a:defRPr>
             </a:pPr>
             <a:r>
-              <a:t>✨ 制造商</a:t>
-            </a:r>
-          </a:p>
-          <a:p>
-            <a:pPr>
-              <a:defRPr sz="1100" b="1">
-                <a:solidFill>
-                  <a:srgbClr val="0F172A"/>
-                </a:solidFill>
-                <a:latin typeface="微软雅黑"/>
-              </a:defRPr>
-            </a:pPr>
-            <a:r>
-              <a:t>电力电子</a:t>
-            </a:r>
-          </a:p>
-        </p:txBody>
-      </p:sp>
-      <p:sp>
-        <p:nvSpPr>
-          <p:cNvPr id="13" name="Rounded Rectangle 12"/>
+              <a:t>✨ 名称：限位开关支架</a:t>
+            </a:r>
+          </a:p>
+        </p:txBody>
+      </p:sp>
+      <p:sp>
+        <p:nvSpPr>
+          <p:cNvPr id="20" name="Rounded Rectangle 19"/>
           <p:cNvSpPr/>
           <p:nvPr/>
         </p:nvSpPr>
         <p:spPr>
           <a:xfrm>
-            <a:off x="731520" y="3246120"/>
-            <a:ext cx="10728655" cy="1389888"/>
+            <a:off x="7708392" y="4233672"/>
+            <a:ext cx="1755648" cy="548640"/>
+          </a:xfrm>
+          <a:prstGeom prst="roundRect">
+            <a:avLst/>
+          </a:prstGeom>
+          <a:solidFill>
+            <a:srgbClr val="ECFDF5"/>
+          </a:solidFill>
+          <a:ln>
+            <a:solidFill>
+              <a:srgbClr val="A7F3D0"/>
+            </a:solidFill>
+          </a:ln>
+        </p:spPr>
+        <p:style>
+          <a:lnRef idx="1">
+            <a:schemeClr val="accent1"/>
+          </a:lnRef>
+          <a:fillRef idx="3">
+            <a:schemeClr val="accent1"/>
+          </a:fillRef>
+          <a:effectRef idx="2">
+            <a:schemeClr val="accent1"/>
+          </a:effectRef>
+          <a:fontRef idx="minor">
+            <a:schemeClr val="lt1"/>
+          </a:fontRef>
+        </p:style>
+        <p:txBody>
+          <a:bodyPr rtlCol="0" anchor="ctr" wrap="square"/>
+          <a:lstStyle/>
+          <a:p>
+            <a:pPr algn="ctr">
+              <a:defRPr sz="950" b="1">
+                <a:solidFill>
+                  <a:srgbClr val="047857"/>
+                </a:solidFill>
+                <a:latin typeface="微软雅黑"/>
+              </a:defRPr>
+            </a:pPr>
+            <a:r>
+              <a:t>✨ 型号：66-31-02-Q00448-00</a:t>
+            </a:r>
+          </a:p>
+        </p:txBody>
+      </p:sp>
+      <p:sp>
+        <p:nvSpPr>
+          <p:cNvPr id="21" name="Rounded Rectangle 20"/>
+          <p:cNvSpPr/>
+          <p:nvPr/>
+        </p:nvSpPr>
+        <p:spPr>
+          <a:xfrm>
+            <a:off x="9518904" y="4233672"/>
+            <a:ext cx="1755648" cy="548640"/>
+          </a:xfrm>
+          <a:prstGeom prst="roundRect">
+            <a:avLst/>
+          </a:prstGeom>
+          <a:solidFill>
+            <a:srgbClr val="ECFDF5"/>
+          </a:solidFill>
+          <a:ln>
+            <a:solidFill>
+              <a:srgbClr val="A7F3D0"/>
+            </a:solidFill>
+          </a:ln>
+        </p:spPr>
+        <p:style>
+          <a:lnRef idx="1">
+            <a:schemeClr val="accent1"/>
+          </a:lnRef>
+          <a:fillRef idx="3">
+            <a:schemeClr val="accent1"/>
+          </a:fillRef>
+          <a:effectRef idx="2">
+            <a:schemeClr val="accent1"/>
+          </a:effectRef>
+          <a:fontRef idx="minor">
+            <a:schemeClr val="lt1"/>
+          </a:fontRef>
+        </p:style>
+        <p:txBody>
+          <a:bodyPr rtlCol="0" anchor="ctr" wrap="square"/>
+          <a:lstStyle/>
+          <a:p>
+            <a:pPr algn="ctr">
+              <a:defRPr sz="950" b="1">
+                <a:solidFill>
+                  <a:srgbClr val="047857"/>
+                </a:solidFill>
+                <a:latin typeface="微软雅黑"/>
+              </a:defRPr>
+            </a:pPr>
+            <a:r>
+              <a:t>✨ 厂商：SSB</a:t>
+            </a:r>
+          </a:p>
+        </p:txBody>
+      </p:sp>
+      <p:sp>
+        <p:nvSpPr>
+          <p:cNvPr id="22" name="Rounded Rectangle 21"/>
+          <p:cNvSpPr/>
+          <p:nvPr/>
+        </p:nvSpPr>
+        <p:spPr>
+          <a:xfrm>
+            <a:off x="5760720" y="4983480"/>
+            <a:ext cx="5699455" cy="1536192"/>
           </a:xfrm>
           <a:prstGeom prst="roundRect">
             <a:avLst/>
@@ -9352,14 +9754,14 @@
       </p:sp>
       <p:sp>
         <p:nvSpPr>
-          <p:cNvPr id="14" name="TextBox 13"/>
+          <p:cNvPr id="23" name="TextBox 22"/>
           <p:cNvSpPr txBox="1"/>
           <p:nvPr/>
         </p:nvSpPr>
         <p:spPr>
           <a:xfrm>
-            <a:off x="914400" y="3300984"/>
-            <a:ext cx="10332720" cy="320040"/>
+            <a:off x="5897880" y="5056632"/>
+            <a:ext cx="5394960" cy="292608"/>
           </a:xfrm>
           <a:prstGeom prst="rect">
             <a:avLst/>
@@ -9373,7 +9775,7 @@
           <a:lstStyle/>
           <a:p>
             <a:pPr>
-              <a:defRPr sz="1200" b="1">
+              <a:defRPr sz="1150" b="1">
                 <a:solidFill>
                   <a:srgbClr val="1E3A8A"/>
                 </a:solidFill>
@@ -9381,21 +9783,21 @@
               </a:defRPr>
             </a:pPr>
             <a:r>
-              <a:t>案例 2：词序完全倒置混排（属性前置干扰）</a:t>
-            </a:r>
-          </a:p>
-        </p:txBody>
-      </p:sp>
-      <p:sp>
-        <p:nvSpPr>
-          <p:cNvPr id="15" name="Rounded Rectangle 14"/>
+              <a:t>案例 3：国际外企英文品牌混写（易导致一物多码）</a:t>
+            </a:r>
+          </a:p>
+        </p:txBody>
+      </p:sp>
+      <p:sp>
+        <p:nvSpPr>
+          <p:cNvPr id="24" name="Rounded Rectangle 23"/>
           <p:cNvSpPr/>
           <p:nvPr/>
         </p:nvSpPr>
         <p:spPr>
           <a:xfrm>
-            <a:off x="914400" y="3685032"/>
-            <a:ext cx="3931920" cy="777240"/>
+            <a:off x="5897880" y="5385816"/>
+            <a:ext cx="5394960" cy="438912"/>
           </a:xfrm>
           <a:prstGeom prst="roundRect">
             <a:avLst/>
@@ -9436,43 +9838,32 @@
               </a:defRPr>
             </a:pPr>
             <a:r>
-              <a:t>📥 原始非标描述输入：</a:t>
-            </a:r>
-          </a:p>
-          <a:p>
-            <a:pPr>
-              <a:defRPr sz="1100" b="1">
-                <a:solidFill>
-                  <a:srgbClr val="0F172A"/>
-                </a:solidFill>
-                <a:latin typeface="Segoe UI"/>
-              </a:defRPr>
-            </a:pPr>
-            <a:r>
-              <a:t>支架_66-31-02-Q00448-00_限位开关支架_X3_SSB</a:t>
-            </a:r>
-          </a:p>
-        </p:txBody>
-      </p:sp>
-      <p:sp>
-        <p:nvSpPr>
-          <p:cNvPr id="16" name="Right Arrow 15"/>
+              <a:t>📥 原始描述：维护开关_3LD2704-0TK51_Siemens</a:t>
+            </a:r>
+          </a:p>
+        </p:txBody>
+      </p:sp>
+      <p:sp>
+        <p:nvSpPr>
+          <p:cNvPr id="25" name="Rounded Rectangle 24"/>
           <p:cNvSpPr/>
           <p:nvPr/>
         </p:nvSpPr>
         <p:spPr>
           <a:xfrm>
-            <a:off x="4983480" y="3904488"/>
-            <a:ext cx="320040" cy="347472"/>
-          </a:xfrm>
-          <a:prstGeom prst="rightArrow">
-            <a:avLst/>
-          </a:prstGeom>
-          <a:solidFill>
-            <a:srgbClr val="1D4ED8"/>
+            <a:off x="5897880" y="5879592"/>
+            <a:ext cx="1755648" cy="548640"/>
+          </a:xfrm>
+          <a:prstGeom prst="roundRect">
+            <a:avLst/>
+          </a:prstGeom>
+          <a:solidFill>
+            <a:srgbClr val="ECFDF5"/>
           </a:solidFill>
           <a:ln>
-            <a:noFill/>
+            <a:solidFill>
+              <a:srgbClr val="A7F3D0"/>
+            </a:solidFill>
           </a:ln>
         </p:spPr>
         <p:style>
@@ -9490,23 +9881,33 @@
           </a:fontRef>
         </p:style>
         <p:txBody>
-          <a:bodyPr rtlCol="0" anchor="ctr"/>
-          <a:lstStyle/>
-          <a:p>
-            <a:pPr algn="ctr"/>
-          </a:p>
-        </p:txBody>
-      </p:sp>
-      <p:sp>
-        <p:nvSpPr>
-          <p:cNvPr id="17" name="Rounded Rectangle 16"/>
+          <a:bodyPr rtlCol="0" anchor="ctr" wrap="square"/>
+          <a:lstStyle/>
+          <a:p>
+            <a:pPr algn="ctr">
+              <a:defRPr sz="950" b="1">
+                <a:solidFill>
+                  <a:srgbClr val="047857"/>
+                </a:solidFill>
+                <a:latin typeface="微软雅黑"/>
+              </a:defRPr>
+            </a:pPr>
+            <a:r>
+              <a:t>✨ 名称：维护开关</a:t>
+            </a:r>
+          </a:p>
+        </p:txBody>
+      </p:sp>
+      <p:sp>
+        <p:nvSpPr>
+          <p:cNvPr id="26" name="Rounded Rectangle 25"/>
           <p:cNvSpPr/>
           <p:nvPr/>
         </p:nvSpPr>
         <p:spPr>
           <a:xfrm>
-            <a:off x="5440680" y="3685032"/>
-            <a:ext cx="1874519" cy="777240"/>
+            <a:off x="7708392" y="5879592"/>
+            <a:ext cx="1755648" cy="548640"/>
           </a:xfrm>
           <a:prstGeom prst="roundRect">
             <a:avLst/>
@@ -9539,7 +9940,7 @@
           <a:lstStyle/>
           <a:p>
             <a:pPr algn="ctr">
-              <a:defRPr sz="950">
+              <a:defRPr sz="950" b="1">
                 <a:solidFill>
                   <a:srgbClr val="047857"/>
                 </a:solidFill>
@@ -9547,34 +9948,21 @@
               </a:defRPr>
             </a:pPr>
             <a:r>
-              <a:t>✨ 物料名称</a:t>
-            </a:r>
-          </a:p>
-          <a:p>
-            <a:pPr>
-              <a:defRPr sz="1100" b="1">
-                <a:solidFill>
-                  <a:srgbClr val="0F172A"/>
-                </a:solidFill>
-                <a:latin typeface="微软雅黑"/>
-              </a:defRPr>
-            </a:pPr>
-            <a:r>
-              <a:t>限位开关支架</a:t>
-            </a:r>
-          </a:p>
-        </p:txBody>
-      </p:sp>
-      <p:sp>
-        <p:nvSpPr>
-          <p:cNvPr id="18" name="Rounded Rectangle 17"/>
+              <a:t>✨ 型号：3LD2704-0TK51</a:t>
+            </a:r>
+          </a:p>
+        </p:txBody>
+      </p:sp>
+      <p:sp>
+        <p:nvSpPr>
+          <p:cNvPr id="27" name="Rounded Rectangle 26"/>
           <p:cNvSpPr/>
           <p:nvPr/>
         </p:nvSpPr>
         <p:spPr>
           <a:xfrm>
-            <a:off x="7406640" y="3685032"/>
-            <a:ext cx="1874519" cy="777240"/>
+            <a:off x="9518904" y="5879592"/>
+            <a:ext cx="1755648" cy="548640"/>
           </a:xfrm>
           <a:prstGeom prst="roundRect">
             <a:avLst/>
@@ -9607,7 +9995,7 @@
           <a:lstStyle/>
           <a:p>
             <a:pPr algn="ctr">
-              <a:defRPr sz="950">
+              <a:defRPr sz="950" b="1">
                 <a:solidFill>
                   <a:srgbClr val="047857"/>
                 </a:solidFill>
@@ -9615,484 +10003,7 @@
               </a:defRPr>
             </a:pPr>
             <a:r>
-              <a:t>✨ 规格型号</a:t>
-            </a:r>
-          </a:p>
-          <a:p>
-            <a:pPr>
-              <a:defRPr sz="1100" b="1">
-                <a:solidFill>
-                  <a:srgbClr val="0F172A"/>
-                </a:solidFill>
-                <a:latin typeface="微软雅黑"/>
-              </a:defRPr>
-            </a:pPr>
-            <a:r>
-              <a:t>66-31-02-Q00448-00</a:t>
-            </a:r>
-          </a:p>
-        </p:txBody>
-      </p:sp>
-      <p:sp>
-        <p:nvSpPr>
-          <p:cNvPr id="19" name="Rounded Rectangle 18"/>
-          <p:cNvSpPr/>
-          <p:nvPr/>
-        </p:nvSpPr>
-        <p:spPr>
-          <a:xfrm>
-            <a:off x="9372600" y="3685032"/>
-            <a:ext cx="1874519" cy="777240"/>
-          </a:xfrm>
-          <a:prstGeom prst="roundRect">
-            <a:avLst/>
-          </a:prstGeom>
-          <a:solidFill>
-            <a:srgbClr val="ECFDF5"/>
-          </a:solidFill>
-          <a:ln>
-            <a:solidFill>
-              <a:srgbClr val="A7F3D0"/>
-            </a:solidFill>
-          </a:ln>
-        </p:spPr>
-        <p:style>
-          <a:lnRef idx="1">
-            <a:schemeClr val="accent1"/>
-          </a:lnRef>
-          <a:fillRef idx="3">
-            <a:schemeClr val="accent1"/>
-          </a:fillRef>
-          <a:effectRef idx="2">
-            <a:schemeClr val="accent1"/>
-          </a:effectRef>
-          <a:fontRef idx="minor">
-            <a:schemeClr val="lt1"/>
-          </a:fontRef>
-        </p:style>
-        <p:txBody>
-          <a:bodyPr rtlCol="0" anchor="ctr" wrap="square"/>
-          <a:lstStyle/>
-          <a:p>
-            <a:pPr algn="ctr">
-              <a:defRPr sz="950">
-                <a:solidFill>
-                  <a:srgbClr val="047857"/>
-                </a:solidFill>
-                <a:latin typeface="微软雅黑"/>
-              </a:defRPr>
-            </a:pPr>
-            <a:r>
-              <a:t>✨ 制造商</a:t>
-            </a:r>
-          </a:p>
-          <a:p>
-            <a:pPr>
-              <a:defRPr sz="1100" b="1">
-                <a:solidFill>
-                  <a:srgbClr val="0F172A"/>
-                </a:solidFill>
-                <a:latin typeface="微软雅黑"/>
-              </a:defRPr>
-            </a:pPr>
-            <a:r>
-              <a:t>SSB</a:t>
-            </a:r>
-          </a:p>
-        </p:txBody>
-      </p:sp>
-      <p:sp>
-        <p:nvSpPr>
-          <p:cNvPr id="20" name="Rounded Rectangle 19"/>
-          <p:cNvSpPr/>
-          <p:nvPr/>
-        </p:nvSpPr>
-        <p:spPr>
-          <a:xfrm>
-            <a:off x="731520" y="4800600"/>
-            <a:ext cx="10728655" cy="1389888"/>
-          </a:xfrm>
-          <a:prstGeom prst="roundRect">
-            <a:avLst/>
-          </a:prstGeom>
-          <a:solidFill>
-            <a:srgbClr val="FFFFFF"/>
-          </a:solidFill>
-          <a:ln w="12700">
-            <a:solidFill>
-              <a:srgbClr val="E2E8F0"/>
-            </a:solidFill>
-          </a:ln>
-        </p:spPr>
-        <p:style>
-          <a:lnRef idx="1">
-            <a:schemeClr val="accent1"/>
-          </a:lnRef>
-          <a:fillRef idx="3">
-            <a:schemeClr val="accent1"/>
-          </a:fillRef>
-          <a:effectRef idx="2">
-            <a:schemeClr val="accent1"/>
-          </a:effectRef>
-          <a:fontRef idx="minor">
-            <a:schemeClr val="lt1"/>
-          </a:fontRef>
-        </p:style>
-        <p:txBody>
-          <a:bodyPr rtlCol="0" anchor="ctr"/>
-          <a:lstStyle/>
-          <a:p>
-            <a:pPr algn="ctr"/>
-          </a:p>
-        </p:txBody>
-      </p:sp>
-      <p:sp>
-        <p:nvSpPr>
-          <p:cNvPr id="21" name="TextBox 20"/>
-          <p:cNvSpPr txBox="1"/>
-          <p:nvPr/>
-        </p:nvSpPr>
-        <p:spPr>
-          <a:xfrm>
-            <a:off x="914400" y="4855464"/>
-            <a:ext cx="10332720" cy="320040"/>
-          </a:xfrm>
-          <a:prstGeom prst="rect">
-            <a:avLst/>
-          </a:prstGeom>
-          <a:noFill/>
-        </p:spPr>
-        <p:txBody>
-          <a:bodyPr wrap="none">
-            <a:spAutoFit/>
-          </a:bodyPr>
-          <a:lstStyle/>
-          <a:p>
-            <a:pPr>
-              <a:defRPr sz="1200" b="1">
-                <a:solidFill>
-                  <a:srgbClr val="1E3A8A"/>
-                </a:solidFill>
-                <a:latin typeface="微软雅黑"/>
-              </a:defRPr>
-            </a:pPr>
-            <a:r>
-              <a:t>案例 3：国际外企英文品牌混写（易导致一物多码）</a:t>
-            </a:r>
-          </a:p>
-        </p:txBody>
-      </p:sp>
-      <p:sp>
-        <p:nvSpPr>
-          <p:cNvPr id="22" name="Rounded Rectangle 21"/>
-          <p:cNvSpPr/>
-          <p:nvPr/>
-        </p:nvSpPr>
-        <p:spPr>
-          <a:xfrm>
-            <a:off x="914400" y="5239512"/>
-            <a:ext cx="3931920" cy="777240"/>
-          </a:xfrm>
-          <a:prstGeom prst="roundRect">
-            <a:avLst/>
-          </a:prstGeom>
-          <a:solidFill>
-            <a:srgbClr val="FFF1F2"/>
-          </a:solidFill>
-          <a:ln>
-            <a:solidFill>
-              <a:srgbClr val="FECDD3"/>
-            </a:solidFill>
-          </a:ln>
-        </p:spPr>
-        <p:style>
-          <a:lnRef idx="1">
-            <a:schemeClr val="accent1"/>
-          </a:lnRef>
-          <a:fillRef idx="3">
-            <a:schemeClr val="accent1"/>
-          </a:fillRef>
-          <a:effectRef idx="2">
-            <a:schemeClr val="accent1"/>
-          </a:effectRef>
-          <a:fontRef idx="minor">
-            <a:schemeClr val="lt1"/>
-          </a:fontRef>
-        </p:style>
-        <p:txBody>
-          <a:bodyPr rtlCol="0" anchor="ctr" wrap="square"/>
-          <a:lstStyle/>
-          <a:p>
-            <a:pPr algn="ctr">
-              <a:defRPr sz="950" b="1">
-                <a:solidFill>
-                  <a:srgbClr val="F43F5E"/>
-                </a:solidFill>
-                <a:latin typeface="微软雅黑"/>
-              </a:defRPr>
-            </a:pPr>
-            <a:r>
-              <a:t>📥 原始非标描述输入：</a:t>
-            </a:r>
-          </a:p>
-          <a:p>
-            <a:pPr>
-              <a:defRPr sz="1100" b="1">
-                <a:solidFill>
-                  <a:srgbClr val="0F172A"/>
-                </a:solidFill>
-                <a:latin typeface="Segoe UI"/>
-              </a:defRPr>
-            </a:pPr>
-            <a:r>
-              <a:t>维护开关_3LD2704-0TK51_Siemens</a:t>
-            </a:r>
-          </a:p>
-        </p:txBody>
-      </p:sp>
-      <p:sp>
-        <p:nvSpPr>
-          <p:cNvPr id="23" name="Right Arrow 22"/>
-          <p:cNvSpPr/>
-          <p:nvPr/>
-        </p:nvSpPr>
-        <p:spPr>
-          <a:xfrm>
-            <a:off x="4983480" y="5458968"/>
-            <a:ext cx="320040" cy="347472"/>
-          </a:xfrm>
-          <a:prstGeom prst="rightArrow">
-            <a:avLst/>
-          </a:prstGeom>
-          <a:solidFill>
-            <a:srgbClr val="1D4ED8"/>
-          </a:solidFill>
-          <a:ln>
-            <a:noFill/>
-          </a:ln>
-        </p:spPr>
-        <p:style>
-          <a:lnRef idx="1">
-            <a:schemeClr val="accent1"/>
-          </a:lnRef>
-          <a:fillRef idx="3">
-            <a:schemeClr val="accent1"/>
-          </a:fillRef>
-          <a:effectRef idx="2">
-            <a:schemeClr val="accent1"/>
-          </a:effectRef>
-          <a:fontRef idx="minor">
-            <a:schemeClr val="lt1"/>
-          </a:fontRef>
-        </p:style>
-        <p:txBody>
-          <a:bodyPr rtlCol="0" anchor="ctr"/>
-          <a:lstStyle/>
-          <a:p>
-            <a:pPr algn="ctr"/>
-          </a:p>
-        </p:txBody>
-      </p:sp>
-      <p:sp>
-        <p:nvSpPr>
-          <p:cNvPr id="24" name="Rounded Rectangle 23"/>
-          <p:cNvSpPr/>
-          <p:nvPr/>
-        </p:nvSpPr>
-        <p:spPr>
-          <a:xfrm>
-            <a:off x="5440680" y="5239512"/>
-            <a:ext cx="1874519" cy="777240"/>
-          </a:xfrm>
-          <a:prstGeom prst="roundRect">
-            <a:avLst/>
-          </a:prstGeom>
-          <a:solidFill>
-            <a:srgbClr val="ECFDF5"/>
-          </a:solidFill>
-          <a:ln>
-            <a:solidFill>
-              <a:srgbClr val="A7F3D0"/>
-            </a:solidFill>
-          </a:ln>
-        </p:spPr>
-        <p:style>
-          <a:lnRef idx="1">
-            <a:schemeClr val="accent1"/>
-          </a:lnRef>
-          <a:fillRef idx="3">
-            <a:schemeClr val="accent1"/>
-          </a:fillRef>
-          <a:effectRef idx="2">
-            <a:schemeClr val="accent1"/>
-          </a:effectRef>
-          <a:fontRef idx="minor">
-            <a:schemeClr val="lt1"/>
-          </a:fontRef>
-        </p:style>
-        <p:txBody>
-          <a:bodyPr rtlCol="0" anchor="ctr" wrap="square"/>
-          <a:lstStyle/>
-          <a:p>
-            <a:pPr algn="ctr">
-              <a:defRPr sz="950">
-                <a:solidFill>
-                  <a:srgbClr val="047857"/>
-                </a:solidFill>
-                <a:latin typeface="微软雅黑"/>
-              </a:defRPr>
-            </a:pPr>
-            <a:r>
-              <a:t>✨ 物料名称</a:t>
-            </a:r>
-          </a:p>
-          <a:p>
-            <a:pPr>
-              <a:defRPr sz="1100" b="1">
-                <a:solidFill>
-                  <a:srgbClr val="0F172A"/>
-                </a:solidFill>
-                <a:latin typeface="微软雅黑"/>
-              </a:defRPr>
-            </a:pPr>
-            <a:r>
-              <a:t>维护开关</a:t>
-            </a:r>
-          </a:p>
-        </p:txBody>
-      </p:sp>
-      <p:sp>
-        <p:nvSpPr>
-          <p:cNvPr id="25" name="Rounded Rectangle 24"/>
-          <p:cNvSpPr/>
-          <p:nvPr/>
-        </p:nvSpPr>
-        <p:spPr>
-          <a:xfrm>
-            <a:off x="7406640" y="5239512"/>
-            <a:ext cx="1874519" cy="777240"/>
-          </a:xfrm>
-          <a:prstGeom prst="roundRect">
-            <a:avLst/>
-          </a:prstGeom>
-          <a:solidFill>
-            <a:srgbClr val="ECFDF5"/>
-          </a:solidFill>
-          <a:ln>
-            <a:solidFill>
-              <a:srgbClr val="A7F3D0"/>
-            </a:solidFill>
-          </a:ln>
-        </p:spPr>
-        <p:style>
-          <a:lnRef idx="1">
-            <a:schemeClr val="accent1"/>
-          </a:lnRef>
-          <a:fillRef idx="3">
-            <a:schemeClr val="accent1"/>
-          </a:fillRef>
-          <a:effectRef idx="2">
-            <a:schemeClr val="accent1"/>
-          </a:effectRef>
-          <a:fontRef idx="minor">
-            <a:schemeClr val="lt1"/>
-          </a:fontRef>
-        </p:style>
-        <p:txBody>
-          <a:bodyPr rtlCol="0" anchor="ctr" wrap="square"/>
-          <a:lstStyle/>
-          <a:p>
-            <a:pPr algn="ctr">
-              <a:defRPr sz="950">
-                <a:solidFill>
-                  <a:srgbClr val="047857"/>
-                </a:solidFill>
-                <a:latin typeface="微软雅黑"/>
-              </a:defRPr>
-            </a:pPr>
-            <a:r>
-              <a:t>✨ 规格型号</a:t>
-            </a:r>
-          </a:p>
-          <a:p>
-            <a:pPr>
-              <a:defRPr sz="1100" b="1">
-                <a:solidFill>
-                  <a:srgbClr val="0F172A"/>
-                </a:solidFill>
-                <a:latin typeface="微软雅黑"/>
-              </a:defRPr>
-            </a:pPr>
-            <a:r>
-              <a:t>3LD2704-0TK51</a:t>
-            </a:r>
-          </a:p>
-        </p:txBody>
-      </p:sp>
-      <p:sp>
-        <p:nvSpPr>
-          <p:cNvPr id="26" name="Rounded Rectangle 25"/>
-          <p:cNvSpPr/>
-          <p:nvPr/>
-        </p:nvSpPr>
-        <p:spPr>
-          <a:xfrm>
-            <a:off x="9372600" y="5239512"/>
-            <a:ext cx="1874519" cy="777240"/>
-          </a:xfrm>
-          <a:prstGeom prst="roundRect">
-            <a:avLst/>
-          </a:prstGeom>
-          <a:solidFill>
-            <a:srgbClr val="ECFDF5"/>
-          </a:solidFill>
-          <a:ln>
-            <a:solidFill>
-              <a:srgbClr val="A7F3D0"/>
-            </a:solidFill>
-          </a:ln>
-        </p:spPr>
-        <p:style>
-          <a:lnRef idx="1">
-            <a:schemeClr val="accent1"/>
-          </a:lnRef>
-          <a:fillRef idx="3">
-            <a:schemeClr val="accent1"/>
-          </a:fillRef>
-          <a:effectRef idx="2">
-            <a:schemeClr val="accent1"/>
-          </a:effectRef>
-          <a:fontRef idx="minor">
-            <a:schemeClr val="lt1"/>
-          </a:fontRef>
-        </p:style>
-        <p:txBody>
-          <a:bodyPr rtlCol="0" anchor="ctr" wrap="square"/>
-          <a:lstStyle/>
-          <a:p>
-            <a:pPr algn="ctr">
-              <a:defRPr sz="950">
-                <a:solidFill>
-                  <a:srgbClr val="047857"/>
-                </a:solidFill>
-                <a:latin typeface="微软雅黑"/>
-              </a:defRPr>
-            </a:pPr>
-            <a:r>
-              <a:t>✨ 制造商</a:t>
-            </a:r>
-          </a:p>
-          <a:p>
-            <a:pPr>
-              <a:defRPr sz="1100" b="1">
-                <a:solidFill>
-                  <a:srgbClr val="0F172A"/>
-                </a:solidFill>
-                <a:latin typeface="微软雅黑"/>
-              </a:defRPr>
-            </a:pPr>
-            <a:r>
-              <a:t>西门子</a:t>
+              <a:t>✨ 厂商：西门子 (规范映射)</a:t>
             </a:r>
           </a:p>
         </p:txBody>
@@ -10853,7 +10764,7 @@
               </a:defRPr>
             </a:pPr>
             <a:r>
-              <a:t>06. 业务全流程闭环</a:t>
+              <a:t>06. 最终界面与业务全流程闭环</a:t>
             </a:r>
           </a:p>
         </p:txBody>
@@ -10889,7 +10800,7 @@
               </a:defRPr>
             </a:pPr>
             <a:r>
-              <a:t>从物料推断到受控 Service BOM 自动生成</a:t>
+              <a:t>Service BOM 智能工作站实机运行与受控规范落地</a:t>
             </a:r>
           </a:p>
           <a:p>
@@ -10905,7 +10816,7 @@
               </a:defRPr>
             </a:pPr>
             <a:r>
-              <a:t>严格遵循公司受控规范，兼具灵活编制体验与严密受控的版本控制体系</a:t>
+              <a:t>集统一物料库、装配层级点阵、实物图谱与受控保护于一体的端到端交付平台</a:t>
             </a:r>
           </a:p>
         </p:txBody>
@@ -10919,7 +10830,129 @@
         <p:spPr>
           <a:xfrm>
             <a:off x="731520" y="1691640"/>
-            <a:ext cx="5285232" cy="2103120"/>
+            <a:ext cx="7635240" cy="4846320"/>
+          </a:xfrm>
+          <a:prstGeom prst="roundRect">
+            <a:avLst/>
+          </a:prstGeom>
+          <a:solidFill>
+            <a:srgbClr val="FFFFFF"/>
+          </a:solidFill>
+          <a:ln w="19050">
+            <a:solidFill>
+              <a:srgbClr val="1D4ED8"/>
+            </a:solidFill>
+          </a:ln>
+        </p:spPr>
+        <p:style>
+          <a:lnRef idx="1">
+            <a:schemeClr val="accent1"/>
+          </a:lnRef>
+          <a:fillRef idx="3">
+            <a:schemeClr val="accent1"/>
+          </a:fillRef>
+          <a:effectRef idx="2">
+            <a:schemeClr val="accent1"/>
+          </a:effectRef>
+          <a:fontRef idx="minor">
+            <a:schemeClr val="lt1"/>
+          </a:fontRef>
+        </p:style>
+        <p:txBody>
+          <a:bodyPr rtlCol="0" anchor="ctr"/>
+          <a:lstStyle/>
+          <a:p>
+            <a:pPr algn="ctr"/>
+          </a:p>
+        </p:txBody>
+      </p:sp>
+      <p:sp>
+        <p:nvSpPr>
+          <p:cNvPr id="7" name="Rounded Rectangle 6"/>
+          <p:cNvSpPr/>
+          <p:nvPr/>
+        </p:nvSpPr>
+        <p:spPr>
+          <a:xfrm>
+            <a:off x="731520" y="1691640"/>
+            <a:ext cx="7635240" cy="347472"/>
+          </a:xfrm>
+          <a:prstGeom prst="roundRect">
+            <a:avLst/>
+          </a:prstGeom>
+          <a:solidFill>
+            <a:srgbClr val="0F172A"/>
+          </a:solidFill>
+          <a:ln>
+            <a:noFill/>
+          </a:ln>
+        </p:spPr>
+        <p:style>
+          <a:lnRef idx="1">
+            <a:schemeClr val="accent1"/>
+          </a:lnRef>
+          <a:fillRef idx="3">
+            <a:schemeClr val="accent1"/>
+          </a:fillRef>
+          <a:effectRef idx="2">
+            <a:schemeClr val="accent1"/>
+          </a:effectRef>
+          <a:fontRef idx="minor">
+            <a:schemeClr val="lt1"/>
+          </a:fontRef>
+        </p:style>
+        <p:txBody>
+          <a:bodyPr rtlCol="0" anchor="ctr"/>
+          <a:lstStyle/>
+          <a:p>
+            <a:pPr algn="ctr">
+              <a:defRPr sz="1000" b="1">
+                <a:solidFill>
+                  <a:srgbClr val="FFFFFF"/>
+                </a:solidFill>
+                <a:latin typeface="微软雅黑"/>
+              </a:defRPr>
+            </a:pPr>
+            <a:r>
+              <a:t>🌐 风电机组 Service BOM 智能工作站 · 实时运行界面 (受控项目实机截图)</a:t>
+            </a:r>
+          </a:p>
+        </p:txBody>
+      </p:sp>
+      <p:pic>
+        <p:nvPicPr>
+          <p:cNvPr id="8" name="Picture 7" descr="ui_dashboard_real.png"/>
+          <p:cNvPicPr>
+            <a:picLocks noChangeAspect="1"/>
+          </p:cNvPicPr>
+          <p:nvPr/>
+        </p:nvPicPr>
+        <p:blipFill>
+          <a:blip r:embed="rId2"/>
+          <a:stretch>
+            <a:fillRect/>
+          </a:stretch>
+        </p:blipFill>
+        <p:spPr>
+          <a:xfrm>
+            <a:off x="777240" y="2084831"/>
+            <a:ext cx="7543800" cy="4389120"/>
+          </a:xfrm>
+          <a:prstGeom prst="rect">
+            <a:avLst/>
+          </a:prstGeom>
+        </p:spPr>
+      </p:pic>
+      <p:sp>
+        <p:nvSpPr>
+          <p:cNvPr id="9" name="Rounded Rectangle 8"/>
+          <p:cNvSpPr/>
+          <p:nvPr/>
+        </p:nvSpPr>
+        <p:spPr>
+          <a:xfrm>
+            <a:off x="8503920" y="1691640"/>
+            <a:ext cx="2956255" cy="1133856"/>
           </a:xfrm>
           <a:prstGeom prst="roundRect">
             <a:avLst/>
@@ -10957,14 +10990,14 @@
       </p:sp>
       <p:sp>
         <p:nvSpPr>
-          <p:cNvPr id="7" name="Rounded Rectangle 6"/>
+          <p:cNvPr id="10" name="Rounded Rectangle 9"/>
           <p:cNvSpPr/>
           <p:nvPr/>
         </p:nvSpPr>
         <p:spPr>
           <a:xfrm>
-            <a:off x="960120" y="1892808"/>
-            <a:ext cx="384048" cy="384048"/>
+            <a:off x="8503920" y="1691640"/>
+            <a:ext cx="91440" cy="1133856"/>
           </a:xfrm>
           <a:prstGeom prst="roundRect">
             <a:avLst/>
@@ -10994,30 +11027,20 @@
           <a:bodyPr rtlCol="0" anchor="ctr"/>
           <a:lstStyle/>
           <a:p>
-            <a:pPr algn="ctr">
-              <a:defRPr sz="1400" b="1">
-                <a:solidFill>
-                  <a:srgbClr val="FFFFFF"/>
-                </a:solidFill>
-                <a:latin typeface="Segoe UI"/>
-              </a:defRPr>
-            </a:pPr>
-            <a:r>
-              <a:t>1</a:t>
-            </a:r>
-          </a:p>
-        </p:txBody>
-      </p:sp>
-      <p:sp>
-        <p:nvSpPr>
-          <p:cNvPr id="8" name="TextBox 7"/>
+            <a:pPr algn="ctr"/>
+          </a:p>
+        </p:txBody>
+      </p:sp>
+      <p:sp>
+        <p:nvSpPr>
+          <p:cNvPr id="11" name="TextBox 10"/>
           <p:cNvSpPr txBox="1"/>
           <p:nvPr/>
         </p:nvSpPr>
         <p:spPr>
           <a:xfrm>
-            <a:off x="1444752" y="1856232"/>
-            <a:ext cx="4343400" cy="1828800"/>
+            <a:off x="8668512" y="1746504"/>
+            <a:ext cx="2724912" cy="1051560"/>
           </a:xfrm>
           <a:prstGeom prst="rect">
             <a:avLst/>
@@ -11031,23 +11054,23 @@
           <a:lstStyle/>
           <a:p>
             <a:pPr>
-              <a:defRPr sz="1400" b="1">
-                <a:solidFill>
-                  <a:srgbClr val="1E3A8A"/>
-                </a:solidFill>
-                <a:latin typeface="微软雅黑"/>
-              </a:defRPr>
-            </a:pPr>
-            <a:r>
-              <a:t>受控封面与元数据联动</a:t>
+              <a:defRPr sz="1100" b="1">
+                <a:solidFill>
+                  <a:srgbClr val="1D4ED8"/>
+                </a:solidFill>
+                <a:latin typeface="微软雅黑"/>
+              </a:defRPr>
+            </a:pPr>
+            <a:r>
+              <a:t>🔐 受控工程锁 &amp; 统一命名</a:t>
             </a:r>
           </a:p>
           <a:p>
             <a:pPr>
               <a:spcBef>
-                <a:spcPts val="600"/>
+                <a:spcPts val="300"/>
               </a:spcBef>
-              <a:defRPr sz="1050">
+              <a:defRPr sz="950">
                 <a:solidFill>
                   <a:srgbClr val="475569"/>
                 </a:solidFill>
@@ -11055,21 +11078,21 @@
               </a:defRPr>
             </a:pPr>
             <a:r>
-              <a:t>自动填充受控表单号（FDJL-JS-037）、文件号、机型代号（如 EW6.25-220）、所属平台（如 WL平台）。封面与导出的文件名全流程自动同步，告别手工填写的低级错误。</a:t>
-            </a:r>
-          </a:p>
-        </p:txBody>
-      </p:sp>
-      <p:sp>
-        <p:nvSpPr>
-          <p:cNvPr id="9" name="Rounded Rectangle 8"/>
+              <a:t>项目命名统一遵循：`变桨系统SBOM_电力电子[WL平台][EW6.25-220]`；带工程锁与心跳保护，协同互不冲撞。</a:t>
+            </a:r>
+          </a:p>
+        </p:txBody>
+      </p:sp>
+      <p:sp>
+        <p:nvSpPr>
+          <p:cNvPr id="12" name="Rounded Rectangle 11"/>
           <p:cNvSpPr/>
           <p:nvPr/>
         </p:nvSpPr>
         <p:spPr>
           <a:xfrm>
-            <a:off x="6172200" y="1691640"/>
-            <a:ext cx="5285232" cy="2103120"/>
+            <a:off x="8503920" y="2935224"/>
+            <a:ext cx="2956255" cy="1133856"/>
           </a:xfrm>
           <a:prstGeom prst="roundRect">
             <a:avLst/>
@@ -11107,20 +11130,20 @@
       </p:sp>
       <p:sp>
         <p:nvSpPr>
-          <p:cNvPr id="10" name="Rounded Rectangle 9"/>
+          <p:cNvPr id="13" name="Rounded Rectangle 12"/>
           <p:cNvSpPr/>
           <p:nvPr/>
         </p:nvSpPr>
         <p:spPr>
           <a:xfrm>
-            <a:off x="6400800" y="1892808"/>
-            <a:ext cx="384048" cy="384048"/>
+            <a:off x="8503920" y="2935224"/>
+            <a:ext cx="91440" cy="1133856"/>
           </a:xfrm>
           <a:prstGeom prst="roundRect">
             <a:avLst/>
           </a:prstGeom>
           <a:solidFill>
-            <a:srgbClr val="1D4ED8"/>
+            <a:srgbClr val="10B981"/>
           </a:solidFill>
           <a:ln>
             <a:noFill/>
@@ -11144,30 +11167,20 @@
           <a:bodyPr rtlCol="0" anchor="ctr"/>
           <a:lstStyle/>
           <a:p>
-            <a:pPr algn="ctr">
-              <a:defRPr sz="1400" b="1">
-                <a:solidFill>
-                  <a:srgbClr val="FFFFFF"/>
-                </a:solidFill>
-                <a:latin typeface="Segoe UI"/>
-              </a:defRPr>
-            </a:pPr>
-            <a:r>
-              <a:t>2</a:t>
-            </a:r>
-          </a:p>
-        </p:txBody>
-      </p:sp>
-      <p:sp>
-        <p:nvSpPr>
-          <p:cNvPr id="11" name="TextBox 10"/>
+            <a:pPr algn="ctr"/>
+          </a:p>
+        </p:txBody>
+      </p:sp>
+      <p:sp>
+        <p:nvSpPr>
+          <p:cNvPr id="14" name="TextBox 13"/>
           <p:cNvSpPr txBox="1"/>
           <p:nvPr/>
         </p:nvSpPr>
         <p:spPr>
           <a:xfrm>
-            <a:off x="6885432" y="1856232"/>
-            <a:ext cx="4343400" cy="1828800"/>
+            <a:off x="8668512" y="2990088"/>
+            <a:ext cx="2724912" cy="1051560"/>
           </a:xfrm>
           <a:prstGeom prst="rect">
             <a:avLst/>
@@ -11181,23 +11194,23 @@
           <a:lstStyle/>
           <a:p>
             <a:pPr>
-              <a:defRPr sz="1400" b="1">
-                <a:solidFill>
-                  <a:srgbClr val="1E3A8A"/>
-                </a:solidFill>
-                <a:latin typeface="微软雅黑"/>
-              </a:defRPr>
-            </a:pPr>
-            <a:r>
-              <a:t>六级清单签字与变更页 (ECN)</a:t>
+              <a:defRPr sz="1100" b="1">
+                <a:solidFill>
+                  <a:srgbClr val="10B981"/>
+                </a:solidFill>
+                <a:latin typeface="微软雅黑"/>
+              </a:defRPr>
+            </a:pPr>
+            <a:r>
+              <a:t>🌲 树状层级点阵 &amp; 步进序号</a:t>
             </a:r>
           </a:p>
           <a:p>
             <a:pPr>
               <a:spcBef>
-                <a:spcPts val="600"/>
+                <a:spcPts val="300"/>
               </a:spcBef>
-              <a:defRPr sz="1050">
+              <a:defRPr sz="950">
                 <a:solidFill>
                   <a:srgbClr val="475569"/>
                 </a:solidFill>
@@ -11205,21 +11218,21 @@
               </a:defRPr>
             </a:pPr>
             <a:r>
-              <a:t>严格支持【编制、校对、审核、会签、标审】完整签字责任链；每次机型升级自动生成 ECN 修改通知单记录与更改标记，全流程合规可溯。</a:t>
-            </a:r>
-          </a:p>
-        </p:txBody>
-      </p:sp>
-      <p:sp>
-        <p:nvSpPr>
-          <p:cNvPr id="12" name="Rounded Rectangle 11"/>
+              <a:t>规范“10, 20, 30”步进序号编码；自动计算并生成 `• 一级组件` / `•• 二级` 层级缩进，导出完美还原。</a:t>
+            </a:r>
+          </a:p>
+        </p:txBody>
+      </p:sp>
+      <p:sp>
+        <p:nvSpPr>
+          <p:cNvPr id="15" name="Rounded Rectangle 14"/>
           <p:cNvSpPr/>
           <p:nvPr/>
         </p:nvSpPr>
         <p:spPr>
           <a:xfrm>
-            <a:off x="731520" y="3977639"/>
-            <a:ext cx="5285232" cy="2103120"/>
+            <a:off x="8503920" y="4178808"/>
+            <a:ext cx="2956255" cy="1133856"/>
           </a:xfrm>
           <a:prstGeom prst="roundRect">
             <a:avLst/>
@@ -11257,20 +11270,20 @@
       </p:sp>
       <p:sp>
         <p:nvSpPr>
-          <p:cNvPr id="13" name="Rounded Rectangle 12"/>
+          <p:cNvPr id="16" name="Rounded Rectangle 15"/>
           <p:cNvSpPr/>
           <p:nvPr/>
         </p:nvSpPr>
         <p:spPr>
           <a:xfrm>
-            <a:off x="960120" y="4178807"/>
-            <a:ext cx="384048" cy="384048"/>
+            <a:off x="8503920" y="4178808"/>
+            <a:ext cx="91440" cy="1133856"/>
           </a:xfrm>
           <a:prstGeom prst="roundRect">
             <a:avLst/>
           </a:prstGeom>
           <a:solidFill>
-            <a:srgbClr val="1D4ED8"/>
+            <a:srgbClr val="0EA5E9"/>
           </a:solidFill>
           <a:ln>
             <a:noFill/>
@@ -11294,30 +11307,20 @@
           <a:bodyPr rtlCol="0" anchor="ctr"/>
           <a:lstStyle/>
           <a:p>
-            <a:pPr algn="ctr">
-              <a:defRPr sz="1400" b="1">
-                <a:solidFill>
-                  <a:srgbClr val="FFFFFF"/>
-                </a:solidFill>
-                <a:latin typeface="Segoe UI"/>
-              </a:defRPr>
-            </a:pPr>
-            <a:r>
-              <a:t>3</a:t>
-            </a:r>
-          </a:p>
-        </p:txBody>
-      </p:sp>
-      <p:sp>
-        <p:nvSpPr>
-          <p:cNvPr id="14" name="TextBox 13"/>
+            <a:pPr algn="ctr"/>
+          </a:p>
+        </p:txBody>
+      </p:sp>
+      <p:sp>
+        <p:nvSpPr>
+          <p:cNvPr id="17" name="TextBox 16"/>
           <p:cNvSpPr txBox="1"/>
           <p:nvPr/>
         </p:nvSpPr>
         <p:spPr>
           <a:xfrm>
-            <a:off x="1444752" y="4142231"/>
-            <a:ext cx="4343400" cy="1828800"/>
+            <a:off x="8668512" y="4233672"/>
+            <a:ext cx="2724912" cy="1051560"/>
           </a:xfrm>
           <a:prstGeom prst="rect">
             <a:avLst/>
@@ -11331,23 +11334,23 @@
           <a:lstStyle/>
           <a:p>
             <a:pPr>
-              <a:defRPr sz="1400" b="1">
-                <a:solidFill>
-                  <a:srgbClr val="1E3A8A"/>
-                </a:solidFill>
-                <a:latin typeface="微软雅黑"/>
-              </a:defRPr>
-            </a:pPr>
-            <a:r>
-              <a:t>树状层级序号规则 (Step 10)</a:t>
+              <a:defRPr sz="1100" b="1">
+                <a:solidFill>
+                  <a:srgbClr val="0EA5E9"/>
+                </a:solidFill>
+                <a:latin typeface="微软雅黑"/>
+              </a:defRPr>
+            </a:pPr>
+            <a:r>
+              <a:t>📸 多模态实物图册 &amp; 手册</a:t>
             </a:r>
           </a:p>
           <a:p>
             <a:pPr>
               <a:spcBef>
-                <a:spcPts val="600"/>
+                <a:spcPts val="300"/>
               </a:spcBef>
-              <a:defRPr sz="1050">
+              <a:defRPr sz="950">
                 <a:solidFill>
                   <a:srgbClr val="475569"/>
                 </a:solidFill>
@@ -11355,21 +11358,21 @@
               </a:defRPr>
             </a:pPr>
             <a:r>
-              <a:t>支持国际通行标准“10、20、30”步进序号编码，并自动生成 B 列层级点阵缩进（•、••、•••），多层级关系一目了然，Excel 导出完美还原。</a:t>
-            </a:r>
-          </a:p>
-        </p:txBody>
-      </p:sp>
-      <p:sp>
-        <p:nvSpPr>
-          <p:cNvPr id="15" name="Rounded Rectangle 14"/>
+              <a:t>清单内嵌继电器、电源、电机等实物缩略图，现场领料秒级核对；一键调阅对应 PDF 技术手册。</a:t>
+            </a:r>
+          </a:p>
+        </p:txBody>
+      </p:sp>
+      <p:sp>
+        <p:nvSpPr>
+          <p:cNvPr id="18" name="Rounded Rectangle 17"/>
           <p:cNvSpPr/>
           <p:nvPr/>
         </p:nvSpPr>
         <p:spPr>
           <a:xfrm>
-            <a:off x="6172200" y="3977639"/>
-            <a:ext cx="5285232" cy="2103120"/>
+            <a:off x="8503920" y="5422392"/>
+            <a:ext cx="2956255" cy="1133856"/>
           </a:xfrm>
           <a:prstGeom prst="roundRect">
             <a:avLst/>
@@ -11407,20 +11410,20 @@
       </p:sp>
       <p:sp>
         <p:nvSpPr>
-          <p:cNvPr id="16" name="Rounded Rectangle 15"/>
+          <p:cNvPr id="19" name="Rounded Rectangle 18"/>
           <p:cNvSpPr/>
           <p:nvPr/>
         </p:nvSpPr>
         <p:spPr>
           <a:xfrm>
-            <a:off x="6400800" y="4178807"/>
-            <a:ext cx="384048" cy="384048"/>
+            <a:off x="8503920" y="5422392"/>
+            <a:ext cx="91440" cy="1133856"/>
           </a:xfrm>
           <a:prstGeom prst="roundRect">
             <a:avLst/>
           </a:prstGeom>
           <a:solidFill>
-            <a:srgbClr val="1D4ED8"/>
+            <a:srgbClr val="7C3AED"/>
           </a:solidFill>
           <a:ln>
             <a:noFill/>
@@ -11444,30 +11447,20 @@
           <a:bodyPr rtlCol="0" anchor="ctr"/>
           <a:lstStyle/>
           <a:p>
-            <a:pPr algn="ctr">
-              <a:defRPr sz="1400" b="1">
-                <a:solidFill>
-                  <a:srgbClr val="FFFFFF"/>
-                </a:solidFill>
-                <a:latin typeface="Segoe UI"/>
-              </a:defRPr>
-            </a:pPr>
-            <a:r>
-              <a:t>4</a:t>
-            </a:r>
-          </a:p>
-        </p:txBody>
-      </p:sp>
-      <p:sp>
-        <p:nvSpPr>
-          <p:cNvPr id="17" name="TextBox 16"/>
+            <a:pPr algn="ctr"/>
+          </a:p>
+        </p:txBody>
+      </p:sp>
+      <p:sp>
+        <p:nvSpPr>
+          <p:cNvPr id="20" name="TextBox 19"/>
           <p:cNvSpPr txBox="1"/>
           <p:nvPr/>
         </p:nvSpPr>
         <p:spPr>
           <a:xfrm>
-            <a:off x="6885432" y="4142231"/>
-            <a:ext cx="4343400" cy="1828800"/>
+            <a:off x="8668512" y="5477256"/>
+            <a:ext cx="2724912" cy="1051560"/>
           </a:xfrm>
           <a:prstGeom prst="rect">
             <a:avLst/>
@@ -11481,23 +11474,23 @@
           <a:lstStyle/>
           <a:p>
             <a:pPr>
-              <a:defRPr sz="1400" b="1">
-                <a:solidFill>
-                  <a:srgbClr val="1E3A8A"/>
-                </a:solidFill>
-                <a:latin typeface="微软雅黑"/>
-              </a:defRPr>
-            </a:pPr>
-            <a:r>
-              <a:t>细粒度工程锁保护机制</a:t>
+              <a:defRPr sz="1100" b="1">
+                <a:solidFill>
+                  <a:srgbClr val="7C3AED"/>
+                </a:solidFill>
+                <a:latin typeface="微软雅黑"/>
+              </a:defRPr>
+            </a:pPr>
+            <a:r>
+              <a:t>📤 受控规范标准交付闭环</a:t>
             </a:r>
           </a:p>
           <a:p>
             <a:pPr>
               <a:spcBef>
-                <a:spcPts val="600"/>
+                <a:spcPts val="300"/>
               </a:spcBef>
-              <a:defRPr sz="1050">
+              <a:defRPr sz="950">
                 <a:solidFill>
                   <a:srgbClr val="475569"/>
                 </a:solidFill>
@@ -11505,7 +11498,7 @@
               </a:defRPr>
             </a:pPr>
             <a:r>
-              <a:t>独立机型工程锁（锁定只读 / 解锁编辑），多位同事在局域网协同办公互不冲撞覆盖，自带心跳监测与离线自动释放，兼顾安全与效率。</a:t>
+              <a:t>100% 契合 FDJL-JS-037 受控表单规范，含封面、签字与更改页；一键打包离线运维工程包 (.zip)。</a:t>
             </a:r>
           </a:p>
         </p:txBody>

</xml_diff>